<commit_message>
edited the design of the presentation
</commit_message>
<xml_diff>
--- a/Presentation.pptx
+++ b/Presentation.pptx
@@ -315,7 +315,7 @@
           <a:p>
             <a:fld id="{5BCAD085-E8A6-8845-BD4E-CB4CCA059FC4}" type="datetimeFigureOut">
               <a:rPr lang="en-US" smtClean="0"/>
-              <a:t>6/19/25</a:t>
+              <a:t>6/21/2025</a:t>
             </a:fld>
             <a:endParaRPr lang="en-US"/>
           </a:p>
@@ -483,7 +483,7 @@
           <a:p>
             <a:fld id="{5BCAD085-E8A6-8845-BD4E-CB4CCA059FC4}" type="datetimeFigureOut">
               <a:rPr lang="en-US" smtClean="0"/>
-              <a:t>6/19/25</a:t>
+              <a:t>6/21/2025</a:t>
             </a:fld>
             <a:endParaRPr lang="en-US"/>
           </a:p>
@@ -661,7 +661,7 @@
           <a:p>
             <a:fld id="{5BCAD085-E8A6-8845-BD4E-CB4CCA059FC4}" type="datetimeFigureOut">
               <a:rPr lang="en-US" smtClean="0"/>
-              <a:t>6/19/25</a:t>
+              <a:t>6/21/2025</a:t>
             </a:fld>
             <a:endParaRPr lang="en-US"/>
           </a:p>
@@ -829,7 +829,7 @@
           <a:p>
             <a:fld id="{5BCAD085-E8A6-8845-BD4E-CB4CCA059FC4}" type="datetimeFigureOut">
               <a:rPr lang="en-US" smtClean="0"/>
-              <a:t>6/19/25</a:t>
+              <a:t>6/21/2025</a:t>
             </a:fld>
             <a:endParaRPr lang="en-US"/>
           </a:p>
@@ -1074,7 +1074,7 @@
           <a:p>
             <a:fld id="{5BCAD085-E8A6-8845-BD4E-CB4CCA059FC4}" type="datetimeFigureOut">
               <a:rPr lang="en-US" smtClean="0"/>
-              <a:t>6/19/25</a:t>
+              <a:t>6/21/2025</a:t>
             </a:fld>
             <a:endParaRPr lang="en-US"/>
           </a:p>
@@ -1359,7 +1359,7 @@
           <a:p>
             <a:fld id="{5BCAD085-E8A6-8845-BD4E-CB4CCA059FC4}" type="datetimeFigureOut">
               <a:rPr lang="en-US" smtClean="0"/>
-              <a:t>6/19/25</a:t>
+              <a:t>6/21/2025</a:t>
             </a:fld>
             <a:endParaRPr lang="en-US"/>
           </a:p>
@@ -1778,7 +1778,7 @@
           <a:p>
             <a:fld id="{5BCAD085-E8A6-8845-BD4E-CB4CCA059FC4}" type="datetimeFigureOut">
               <a:rPr lang="en-US" smtClean="0"/>
-              <a:t>6/19/25</a:t>
+              <a:t>6/21/2025</a:t>
             </a:fld>
             <a:endParaRPr lang="en-US"/>
           </a:p>
@@ -1895,7 +1895,7 @@
           <a:p>
             <a:fld id="{5BCAD085-E8A6-8845-BD4E-CB4CCA059FC4}" type="datetimeFigureOut">
               <a:rPr lang="en-US" smtClean="0"/>
-              <a:t>6/19/25</a:t>
+              <a:t>6/21/2025</a:t>
             </a:fld>
             <a:endParaRPr lang="en-US"/>
           </a:p>
@@ -1990,7 +1990,7 @@
           <a:p>
             <a:fld id="{5BCAD085-E8A6-8845-BD4E-CB4CCA059FC4}" type="datetimeFigureOut">
               <a:rPr lang="en-US" smtClean="0"/>
-              <a:t>6/19/25</a:t>
+              <a:t>6/21/2025</a:t>
             </a:fld>
             <a:endParaRPr lang="en-US"/>
           </a:p>
@@ -2265,7 +2265,7 @@
           <a:p>
             <a:fld id="{5BCAD085-E8A6-8845-BD4E-CB4CCA059FC4}" type="datetimeFigureOut">
               <a:rPr lang="en-US" smtClean="0"/>
-              <a:t>6/19/25</a:t>
+              <a:t>6/21/2025</a:t>
             </a:fld>
             <a:endParaRPr lang="en-US"/>
           </a:p>
@@ -2517,7 +2517,7 @@
           <a:p>
             <a:fld id="{5BCAD085-E8A6-8845-BD4E-CB4CCA059FC4}" type="datetimeFigureOut">
               <a:rPr lang="en-US" smtClean="0"/>
-              <a:t>6/19/25</a:t>
+              <a:t>6/21/2025</a:t>
             </a:fld>
             <a:endParaRPr lang="en-US"/>
           </a:p>
@@ -2582,9 +2582,39 @@
 <p:sldMaster xmlns:a="http://schemas.openxmlformats.org/drawingml/2006/main" xmlns:r="http://schemas.openxmlformats.org/officeDocument/2006/relationships" xmlns:p="http://schemas.openxmlformats.org/presentationml/2006/main">
   <p:cSld>
     <p:bg>
-      <p:bgRef idx="1001">
-        <a:schemeClr val="bg1"/>
-      </p:bgRef>
+      <p:bgPr>
+        <a:gradFill flip="none" rotWithShape="1">
+          <a:gsLst>
+            <a:gs pos="0">
+              <a:schemeClr val="accent1">
+                <a:lumMod val="5000"/>
+                <a:lumOff val="95000"/>
+              </a:schemeClr>
+            </a:gs>
+            <a:gs pos="20000">
+              <a:schemeClr val="accent1">
+                <a:lumMod val="45000"/>
+                <a:lumOff val="55000"/>
+              </a:schemeClr>
+            </a:gs>
+            <a:gs pos="83000">
+              <a:schemeClr val="accent1">
+                <a:lumMod val="45000"/>
+                <a:lumOff val="55000"/>
+              </a:schemeClr>
+            </a:gs>
+            <a:gs pos="95000">
+              <a:schemeClr val="accent1">
+                <a:lumMod val="25000"/>
+                <a:lumOff val="75000"/>
+              </a:schemeClr>
+            </a:gs>
+          </a:gsLst>
+          <a:lin ang="2700000" scaled="0"/>
+          <a:tileRect/>
+        </a:gradFill>
+        <a:effectLst/>
+      </p:bgPr>
     </p:bg>
     <p:spTree>
       <p:nvGrpSpPr>
@@ -2728,7 +2758,7 @@
           <a:p>
             <a:fld id="{5BCAD085-E8A6-8845-BD4E-CB4CCA059FC4}" type="datetimeFigureOut">
               <a:rPr lang="en-US" smtClean="0"/>
-              <a:t>6/19/25</a:t>
+              <a:t>6/21/2025</a:t>
             </a:fld>
             <a:endParaRPr lang="en-US"/>
           </a:p>
@@ -3120,12 +3150,14 @@
           </a:xfrm>
         </p:spPr>
         <p:txBody>
-          <a:bodyPr/>
+          <a:bodyPr>
+            <a:normAutofit fontScale="90000"/>
+          </a:bodyPr>
           <a:lstStyle/>
           <a:p>
             <a:r>
               <a:rPr lang="en-GB" b="1" dirty="0"/>
-              <a:t>System</a:t>
+              <a:t>Systems</a:t>
             </a:r>
             <a:r>
               <a:rPr lang="en-GB" dirty="0"/>
@@ -3560,36 +3592,6 @@
           </a:p>
         </p:txBody>
       </p:sp>
-      <p:sp>
-        <p:nvSpPr>
-          <p:cNvPr id="5" name="Content Placeholder 4">
-            <a:extLst>
-              <a:ext uri="{FF2B5EF4-FFF2-40B4-BE49-F238E27FC236}">
-                <a16:creationId xmlns:a16="http://schemas.microsoft.com/office/drawing/2014/main" id="{C49A7BAE-EC94-947B-EA1F-97B4D894B756}"/>
-              </a:ext>
-            </a:extLst>
-          </p:cNvPr>
-          <p:cNvSpPr>
-            <a:spLocks noGrp="1"/>
-          </p:cNvSpPr>
-          <p:nvPr>
-            <p:ph sz="half" idx="2"/>
-          </p:nvPr>
-        </p:nvSpPr>
-        <p:spPr>
-          <a:xfrm>
-            <a:off x="4648200" y="1633727"/>
-            <a:ext cx="4038600" cy="4492436"/>
-          </a:xfrm>
-        </p:spPr>
-        <p:txBody>
-          <a:bodyPr/>
-          <a:lstStyle/>
-          <a:p>
-            <a:endParaRPr lang="en-DE" dirty="0"/>
-          </a:p>
-        </p:txBody>
-      </p:sp>
     </p:spTree>
     <p:extLst>
       <p:ext uri="{BB962C8B-B14F-4D97-AF65-F5344CB8AC3E}">
@@ -4152,6 +4154,94 @@
       </p:grpSpPr>
       <p:sp>
         <p:nvSpPr>
+          <p:cNvPr id="8" name="Rectangle: Rounded Corners 7">
+            <a:extLst>
+              <a:ext uri="{FF2B5EF4-FFF2-40B4-BE49-F238E27FC236}">
+                <a16:creationId xmlns:a16="http://schemas.microsoft.com/office/drawing/2014/main" id="{022E14E2-0171-A899-C741-2FCC5A6CDC79}"/>
+              </a:ext>
+            </a:extLst>
+          </p:cNvPr>
+          <p:cNvSpPr/>
+          <p:nvPr/>
+        </p:nvSpPr>
+        <p:spPr>
+          <a:xfrm>
+            <a:off x="4572000" y="1517766"/>
+            <a:ext cx="3862841" cy="3787772"/>
+          </a:xfrm>
+          <a:prstGeom prst="roundRect">
+            <a:avLst/>
+          </a:prstGeom>
+        </p:spPr>
+        <p:style>
+          <a:lnRef idx="2">
+            <a:schemeClr val="dk1"/>
+          </a:lnRef>
+          <a:fillRef idx="1">
+            <a:schemeClr val="lt1"/>
+          </a:fillRef>
+          <a:effectRef idx="0">
+            <a:schemeClr val="dk1"/>
+          </a:effectRef>
+          <a:fontRef idx="minor">
+            <a:schemeClr val="dk1"/>
+          </a:fontRef>
+        </p:style>
+        <p:txBody>
+          <a:bodyPr rtlCol="0" anchor="ctr"/>
+          <a:lstStyle/>
+          <a:p>
+            <a:pPr algn="ctr"/>
+            <a:endParaRPr lang="en-DE"/>
+          </a:p>
+        </p:txBody>
+      </p:sp>
+      <p:sp>
+        <p:nvSpPr>
+          <p:cNvPr id="3" name="Rectangle: Rounded Corners 2">
+            <a:extLst>
+              <a:ext uri="{FF2B5EF4-FFF2-40B4-BE49-F238E27FC236}">
+                <a16:creationId xmlns:a16="http://schemas.microsoft.com/office/drawing/2014/main" id="{A9DB7287-7D9E-E498-7919-49B7247B5FA9}"/>
+              </a:ext>
+            </a:extLst>
+          </p:cNvPr>
+          <p:cNvSpPr/>
+          <p:nvPr/>
+        </p:nvSpPr>
+        <p:spPr>
+          <a:xfrm>
+            <a:off x="382588" y="1535114"/>
+            <a:ext cx="4114800" cy="2764744"/>
+          </a:xfrm>
+          <a:prstGeom prst="roundRect">
+            <a:avLst/>
+          </a:prstGeom>
+        </p:spPr>
+        <p:style>
+          <a:lnRef idx="2">
+            <a:schemeClr val="dk1"/>
+          </a:lnRef>
+          <a:fillRef idx="1">
+            <a:schemeClr val="lt1"/>
+          </a:fillRef>
+          <a:effectRef idx="0">
+            <a:schemeClr val="dk1"/>
+          </a:effectRef>
+          <a:fontRef idx="minor">
+            <a:schemeClr val="dk1"/>
+          </a:fontRef>
+        </p:style>
+        <p:txBody>
+          <a:bodyPr rtlCol="0" anchor="ctr"/>
+          <a:lstStyle/>
+          <a:p>
+            <a:pPr algn="ctr"/>
+            <a:endParaRPr lang="en-DE"/>
+          </a:p>
+        </p:txBody>
+      </p:sp>
+      <p:sp>
+        <p:nvSpPr>
           <p:cNvPr id="2" name="Title 1"/>
           <p:cNvSpPr>
             <a:spLocks noGrp="1"/>
@@ -4372,7 +4462,12 @@
             <p:ph type="body" sz="quarter" idx="3"/>
           </p:nvPr>
         </p:nvSpPr>
-        <p:spPr/>
+        <p:spPr>
+          <a:xfrm>
+            <a:off x="4644231" y="1535113"/>
+            <a:ext cx="4041775" cy="639762"/>
+          </a:xfrm>
+        </p:spPr>
         <p:txBody>
           <a:bodyPr/>
           <a:lstStyle/>
@@ -4431,13 +4526,14 @@
           <a:p>
             <a:r>
               <a:rPr lang="de-DE" dirty="0"/>
-              <a:t>Arduino + </a:t>
-            </a:r>
-            <a:r>
-              <a:rPr lang="de-DE" dirty="0" err="1"/>
+              <a:t>Arduino</a:t>
+            </a:r>
+          </a:p>
+          <a:p>
+            <a:r>
+              <a:rPr lang="de-DE" dirty="0"/>
               <a:t>Battery</a:t>
             </a:r>
-            <a:endParaRPr lang="de-DE" dirty="0"/>
           </a:p>
           <a:p>
             <a:r>
@@ -4494,10 +4590,10 @@
           <a:lstStyle/>
           <a:p>
             <a:r>
-              <a:rPr lang="en-GB" dirty="0"/>
+              <a:rPr lang="en-GB"/>
               <a:t>Motivation</a:t>
             </a:r>
-            <a:endParaRPr dirty="0"/>
+            <a:endParaRPr lang="en-GB" dirty="0"/>
           </a:p>
         </p:txBody>
       </p:sp>
@@ -4528,7 +4624,7 @@
               </a:defRPr>
             </a:pPr>
             <a:r>
-              <a:rPr lang="en-GB" b="1" dirty="0"/>
+              <a:rPr lang="en-GB" b="1"/>
               <a:t>1. Solving Real-World Problems</a:t>
             </a:r>
           </a:p>
@@ -4544,16 +4640,8 @@
               </a:defRPr>
             </a:pPr>
             <a:r>
-              <a:rPr lang="en-GB" dirty="0"/>
-              <a:t>Simulating core autonomous </a:t>
-            </a:r>
-            <a:r>
-              <a:rPr lang="en-GB" dirty="0" err="1"/>
-              <a:t>behaviors</a:t>
-            </a:r>
-            <a:r>
-              <a:rPr lang="en-GB" dirty="0"/>
-              <a:t> like path planning and obstacle avoidance.</a:t>
+              <a:rPr lang="en-GB"/>
+              <a:t>Simulating autonomous behaviours like line following and obstacle avoidance.</a:t>
             </a:r>
           </a:p>
           <a:p>
@@ -4565,7 +4653,7 @@
                 <a:latin typeface="Calibri"/>
               </a:defRPr>
             </a:pPr>
-            <a:endParaRPr lang="en-GB" dirty="0"/>
+            <a:endParaRPr lang="en-GB"/>
           </a:p>
           <a:p>
             <a:pPr marL="0" indent="0">
@@ -4578,7 +4666,7 @@
               </a:defRPr>
             </a:pPr>
             <a:r>
-              <a:rPr lang="en-GB" b="1" dirty="0"/>
+              <a:rPr lang="en-GB" b="1"/>
               <a:t>2. Interdisciplinary Learning</a:t>
             </a:r>
           </a:p>
@@ -4594,14 +4682,9 @@
               </a:defRPr>
             </a:pPr>
             <a:r>
-              <a:rPr lang="en-GB" dirty="0"/>
-              <a:t>Engineering Design: Prototyping and system </a:t>
-            </a:r>
-            <a:r>
-              <a:rPr lang="en-GB" dirty="0" err="1"/>
-              <a:t>modeling</a:t>
-            </a:r>
-            <a:endParaRPr lang="en-GB" dirty="0"/>
+              <a:rPr lang="en-GB"/>
+              <a:t>Engineering Design: Prototyping and system modelling</a:t>
+            </a:r>
           </a:p>
           <a:p>
             <a:pPr marL="285750" indent="-285750">
@@ -4615,7 +4698,7 @@
               </a:defRPr>
             </a:pPr>
             <a:r>
-              <a:rPr lang="en-GB" dirty="0"/>
+              <a:rPr lang="en-GB"/>
               <a:t>Software: Control logic and algorithm development</a:t>
             </a:r>
           </a:p>
@@ -4631,7 +4714,7 @@
               </a:defRPr>
             </a:pPr>
             <a:r>
-              <a:rPr lang="en-GB" dirty="0"/>
+              <a:rPr lang="en-GB"/>
               <a:t>Hardware: Sensor integration and circuit implementation</a:t>
             </a:r>
           </a:p>
@@ -4647,16 +4730,8 @@
               </a:defRPr>
             </a:pPr>
             <a:r>
-              <a:rPr lang="en-GB" dirty="0"/>
-              <a:t>Systems Engineering: System design (</a:t>
-            </a:r>
-            <a:r>
-              <a:rPr lang="en-GB" dirty="0" err="1"/>
-              <a:t>SysML</a:t>
-            </a:r>
-            <a:r>
-              <a:rPr lang="en-GB" dirty="0"/>
-              <a:t> diagrams), requirements, testing</a:t>
+              <a:rPr lang="en-GB"/>
+              <a:t>Systems Engineering: System design (SysML diagrams), requirements, testing</a:t>
             </a:r>
           </a:p>
           <a:p>
@@ -4668,7 +4743,7 @@
                 <a:latin typeface="Calibri"/>
               </a:defRPr>
             </a:pPr>
-            <a:endParaRPr lang="en-GB" dirty="0"/>
+            <a:endParaRPr lang="en-GB"/>
           </a:p>
           <a:p>
             <a:pPr marL="0" indent="0">
@@ -4681,7 +4756,7 @@
               </a:defRPr>
             </a:pPr>
             <a:r>
-              <a:rPr lang="en-GB" b="1" dirty="0"/>
+              <a:rPr lang="en-GB" b="1"/>
               <a:t>3. Engineering Creativity</a:t>
             </a:r>
           </a:p>
@@ -4697,39 +4772,15 @@
               </a:defRPr>
             </a:pPr>
             <a:r>
-              <a:rPr lang="en-GB" dirty="0"/>
-              <a:t>Handling </a:t>
-            </a:r>
-            <a:r>
-              <a:rPr lang="en-GB" dirty="0" err="1"/>
-              <a:t>vechicle</a:t>
-            </a:r>
-            <a:r>
-              <a:rPr lang="en-GB" dirty="0"/>
-              <a:t> </a:t>
-            </a:r>
-            <a:r>
-              <a:rPr lang="en-GB" dirty="0" err="1"/>
-              <a:t>behavior</a:t>
-            </a:r>
-            <a:r>
-              <a:rPr lang="en-GB" dirty="0"/>
-              <a:t> under hardware constraints: speed control, sensor calibration, </a:t>
-            </a:r>
-            <a:r>
-              <a:rPr lang="en-GB" dirty="0" err="1"/>
-              <a:t>maneuvering</a:t>
-            </a:r>
-            <a:r>
-              <a:rPr lang="en-GB" dirty="0"/>
-              <a:t>.</a:t>
+              <a:rPr lang="en-GB"/>
+              <a:t>Handling vehicle behaviour under hardware constraints: speed control, sensor calibration, manoeuvring.</a:t>
             </a:r>
           </a:p>
           <a:p>
             <a:pPr marL="0" indent="0">
               <a:buNone/>
             </a:pPr>
-            <a:endParaRPr dirty="0"/>
+            <a:endParaRPr lang="en-GB" dirty="0"/>
           </a:p>
         </p:txBody>
       </p:sp>
@@ -5672,7 +5723,7 @@
             </a:pPr>
             <a:r>
               <a:rPr lang="en-GB" sz="2400" dirty="0"/>
-              <a:t>In the construction, the battery is placed at the front of the vehicle for easy access.</a:t>
+              <a:t>In the construction, the battery was placed at the front of the vehicle for easy access.</a:t>
             </a:r>
           </a:p>
           <a:p>
@@ -5719,34 +5770,34 @@
         <a:sysClr val="window" lastClr="FFFFFF"/>
       </a:lt1>
       <a:dk2>
-        <a:srgbClr val="1F497D"/>
+        <a:srgbClr val="0E2841"/>
       </a:dk2>
       <a:lt2>
-        <a:srgbClr val="EEECE1"/>
+        <a:srgbClr val="E8E8E8"/>
       </a:lt2>
       <a:accent1>
-        <a:srgbClr val="4F81BD"/>
+        <a:srgbClr val="156082"/>
       </a:accent1>
       <a:accent2>
-        <a:srgbClr val="C0504D"/>
+        <a:srgbClr val="E97132"/>
       </a:accent2>
       <a:accent3>
-        <a:srgbClr val="9BBB59"/>
+        <a:srgbClr val="196B24"/>
       </a:accent3>
       <a:accent4>
-        <a:srgbClr val="8064A2"/>
+        <a:srgbClr val="0F9ED5"/>
       </a:accent4>
       <a:accent5>
-        <a:srgbClr val="4BACC6"/>
+        <a:srgbClr val="A02B93"/>
       </a:accent5>
       <a:accent6>
-        <a:srgbClr val="F79646"/>
+        <a:srgbClr val="4EA72E"/>
       </a:accent6>
       <a:hlink>
-        <a:srgbClr val="0000FF"/>
+        <a:srgbClr val="467886"/>
       </a:hlink>
       <a:folHlink>
-        <a:srgbClr val="800080"/>
+        <a:srgbClr val="96607D"/>
       </a:folHlink>
     </a:clrScheme>
     <a:fontScheme name="Office">

</xml_diff>

<commit_message>
final updates in the codeand StateMachineDiagram, some corrections in presentatiom
</commit_message>
<xml_diff>
--- a/Presentation.pptx
+++ b/Presentation.pptx
@@ -6267,10 +6267,10 @@
       </p:sp>
       <p:pic>
         <p:nvPicPr>
-          <p:cNvPr id="17" name="Content Placeholder 12">
+          <p:cNvPr id="3" name="Picture 2">
             <a:extLst>
               <a:ext uri="{FF2B5EF4-FFF2-40B4-BE49-F238E27FC236}">
-                <a16:creationId xmlns:a16="http://schemas.microsoft.com/office/drawing/2014/main" id="{752B8AB9-BF81-E4D9-D23C-ACF5CD845BF7}"/>
+                <a16:creationId xmlns:a16="http://schemas.microsoft.com/office/drawing/2014/main" id="{D9F8EBEE-D626-05DD-74A7-EDD8CA39A6A4}"/>
               </a:ext>
             </a:extLst>
           </p:cNvPr>
@@ -6287,8 +6287,8 @@
         </p:blipFill>
         <p:spPr>
           <a:xfrm>
-            <a:off x="4415456" y="1600200"/>
-            <a:ext cx="4271344" cy="2311707"/>
+            <a:off x="4500098" y="1600200"/>
+            <a:ext cx="4347602" cy="3661138"/>
           </a:xfrm>
           <a:prstGeom prst="rect">
             <a:avLst/>
@@ -6430,10 +6430,10 @@
       </p:pic>
       <p:pic>
         <p:nvPicPr>
-          <p:cNvPr id="6" name="Picture 5">
+          <p:cNvPr id="3" name="Picture 2">
             <a:extLst>
               <a:ext uri="{FF2B5EF4-FFF2-40B4-BE49-F238E27FC236}">
-                <a16:creationId xmlns:a16="http://schemas.microsoft.com/office/drawing/2014/main" id="{AA846409-DF24-7AD0-FB5A-B1D15F055838}"/>
+                <a16:creationId xmlns:a16="http://schemas.microsoft.com/office/drawing/2014/main" id="{E46CAD53-1FAC-EA38-4D76-06B08E2CD76C}"/>
               </a:ext>
             </a:extLst>
           </p:cNvPr>
@@ -6450,8 +6450,8 @@
         </p:blipFill>
         <p:spPr>
           <a:xfrm>
-            <a:off x="4771770" y="1607812"/>
-            <a:ext cx="3915030" cy="4513551"/>
+            <a:off x="4648202" y="1600200"/>
+            <a:ext cx="4251593" cy="4510738"/>
           </a:xfrm>
           <a:prstGeom prst="rect">
             <a:avLst/>
@@ -6512,7 +6512,7 @@
         </p:nvSpPr>
         <p:spPr>
           <a:xfrm>
-            <a:off x="457200" y="274638"/>
+            <a:off x="457200" y="188754"/>
             <a:ext cx="8229600" cy="1042098"/>
           </a:xfrm>
         </p:spPr>
@@ -6532,10 +6532,10 @@
       </p:sp>
       <p:pic>
         <p:nvPicPr>
-          <p:cNvPr id="6" name="Content Placeholder 5">
+          <p:cNvPr id="7" name="Content Placeholder 6">
             <a:extLst>
               <a:ext uri="{FF2B5EF4-FFF2-40B4-BE49-F238E27FC236}">
-                <a16:creationId xmlns:a16="http://schemas.microsoft.com/office/drawing/2014/main" id="{94934041-DAE2-87D5-D6C9-6D4E0D9ECBDF}"/>
+                <a16:creationId xmlns:a16="http://schemas.microsoft.com/office/drawing/2014/main" id="{62BA8A05-1F97-D121-3A3D-A66CABEC71A6}"/>
               </a:ext>
             </a:extLst>
           </p:cNvPr>
@@ -6554,8 +6554,8 @@
         </p:blipFill>
         <p:spPr>
           <a:xfrm>
-            <a:off x="2215717" y="1134458"/>
-            <a:ext cx="4712565" cy="5448904"/>
+            <a:off x="2162287" y="1096785"/>
+            <a:ext cx="4819426" cy="5572461"/>
           </a:xfrm>
         </p:spPr>
       </p:pic>
@@ -6694,10 +6694,10 @@
       </p:pic>
       <p:pic>
         <p:nvPicPr>
-          <p:cNvPr id="6" name="Picture 5">
+          <p:cNvPr id="3" name="Picture 2">
             <a:extLst>
               <a:ext uri="{FF2B5EF4-FFF2-40B4-BE49-F238E27FC236}">
-                <a16:creationId xmlns:a16="http://schemas.microsoft.com/office/drawing/2014/main" id="{19447CB0-3A9F-E89B-01DF-44D636194D32}"/>
+                <a16:creationId xmlns:a16="http://schemas.microsoft.com/office/drawing/2014/main" id="{C907B21E-6C4C-42F7-E809-D64205855035}"/>
               </a:ext>
             </a:extLst>
           </p:cNvPr>
@@ -6714,8 +6714,8 @@
         </p:blipFill>
         <p:spPr>
           <a:xfrm>
-            <a:off x="4571999" y="1699054"/>
-            <a:ext cx="4271343" cy="3015066"/>
+            <a:off x="4572000" y="1699054"/>
+            <a:ext cx="4273833" cy="3028657"/>
           </a:xfrm>
           <a:prstGeom prst="rect">
             <a:avLst/>

</xml_diff>

<commit_message>
some small updates in the presentation
</commit_message>
<xml_diff>
--- a/Presentation.pptx
+++ b/Presentation.pptx
@@ -8,13 +8,13 @@
     <p:sldId id="256" r:id="rId2"/>
     <p:sldId id="261" r:id="rId3"/>
     <p:sldId id="262" r:id="rId4"/>
-    <p:sldId id="287" r:id="rId5"/>
-    <p:sldId id="304" r:id="rId6"/>
-    <p:sldId id="307" r:id="rId7"/>
-    <p:sldId id="303" r:id="rId8"/>
-    <p:sldId id="305" r:id="rId9"/>
-    <p:sldId id="306" r:id="rId10"/>
-    <p:sldId id="291" r:id="rId11"/>
+    <p:sldId id="291" r:id="rId5"/>
+    <p:sldId id="287" r:id="rId6"/>
+    <p:sldId id="304" r:id="rId7"/>
+    <p:sldId id="307" r:id="rId8"/>
+    <p:sldId id="303" r:id="rId9"/>
+    <p:sldId id="305" r:id="rId10"/>
+    <p:sldId id="306" r:id="rId11"/>
     <p:sldId id="302" r:id="rId12"/>
     <p:sldId id="288" r:id="rId13"/>
     <p:sldId id="290" r:id="rId14"/>
@@ -3311,7 +3311,7 @@
         <p:cNvPr id="1" name="">
           <a:extLst>
             <a:ext uri="{FF2B5EF4-FFF2-40B4-BE49-F238E27FC236}">
-              <a16:creationId xmlns:a16="http://schemas.microsoft.com/office/drawing/2014/main" id="{2198EAD8-1C28-CB05-398D-86D3D4836CEB}"/>
+              <a16:creationId xmlns:a16="http://schemas.microsoft.com/office/drawing/2014/main" id="{25C9A356-CBAE-6B60-CB48-069FC9518257}"/>
             </a:ext>
           </a:extLst>
         </p:cNvPr>
@@ -3331,7 +3331,7 @@
           <p:cNvPr id="2" name="Title 1">
             <a:extLst>
               <a:ext uri="{FF2B5EF4-FFF2-40B4-BE49-F238E27FC236}">
-                <a16:creationId xmlns:a16="http://schemas.microsoft.com/office/drawing/2014/main" id="{F72B8ECE-66CB-5F7D-1E40-CC592E98F43E}"/>
+                <a16:creationId xmlns:a16="http://schemas.microsoft.com/office/drawing/2014/main" id="{565CC8EE-D829-2C12-7234-56575CE39B81}"/>
               </a:ext>
             </a:extLst>
           </p:cNvPr>
@@ -3342,36 +3342,121 @@
             <p:ph type="title"/>
           </p:nvPr>
         </p:nvSpPr>
+        <p:spPr/>
+        <p:txBody>
+          <a:bodyPr/>
+          <a:lstStyle/>
+          <a:p>
+            <a:r>
+              <a:rPr lang="en-GB" dirty="0"/>
+              <a:t>Updated State Machine</a:t>
+            </a:r>
+            <a:endParaRPr lang="en-DE" dirty="0"/>
+          </a:p>
+        </p:txBody>
+      </p:sp>
+      <p:sp>
+        <p:nvSpPr>
+          <p:cNvPr id="16" name="Content Placeholder 15">
+            <a:extLst>
+              <a:ext uri="{FF2B5EF4-FFF2-40B4-BE49-F238E27FC236}">
+                <a16:creationId xmlns:a16="http://schemas.microsoft.com/office/drawing/2014/main" id="{9E6654EA-C65E-985C-974A-E732CD5C4631}"/>
+              </a:ext>
+            </a:extLst>
+          </p:cNvPr>
+          <p:cNvSpPr>
+            <a:spLocks noGrp="1"/>
+          </p:cNvSpPr>
+          <p:nvPr>
+            <p:ph sz="half" idx="2"/>
+          </p:nvPr>
+        </p:nvSpPr>
         <p:spPr>
           <a:xfrm>
-            <a:off x="457200" y="2686812"/>
-            <a:ext cx="8229600" cy="1143000"/>
+            <a:off x="4572000" y="1699054"/>
+            <a:ext cx="4271344" cy="4525963"/>
           </a:xfrm>
         </p:spPr>
         <p:txBody>
           <a:bodyPr/>
           <a:lstStyle/>
           <a:p>
-            <a:r>
-              <a:rPr dirty="0"/>
-              <a:t>Challenges</a:t>
-            </a:r>
-            <a:r>
-              <a:rPr lang="de-DE" dirty="0"/>
-              <a:t> </a:t>
-            </a:r>
-            <a:r>
-              <a:rPr lang="en-GB" dirty="0"/>
-              <a:t>&amp; Solutions</a:t>
-            </a:r>
-            <a:endParaRPr dirty="0"/>
-          </a:p>
-        </p:txBody>
-      </p:sp>
+            <a:pPr marL="0" indent="0">
+              <a:buNone/>
+            </a:pPr>
+            <a:br>
+              <a:rPr lang="en-DE" dirty="0"/>
+            </a:br>
+            <a:endParaRPr lang="en-DE" dirty="0"/>
+          </a:p>
+        </p:txBody>
+      </p:sp>
+      <p:pic>
+        <p:nvPicPr>
+          <p:cNvPr id="7" name="Content Placeholder 6">
+            <a:extLst>
+              <a:ext uri="{FF2B5EF4-FFF2-40B4-BE49-F238E27FC236}">
+                <a16:creationId xmlns:a16="http://schemas.microsoft.com/office/drawing/2014/main" id="{6B8AFFCB-4070-D76C-B10F-3CB62202C9B8}"/>
+              </a:ext>
+            </a:extLst>
+          </p:cNvPr>
+          <p:cNvPicPr>
+            <a:picLocks noGrp="1" noChangeAspect="1"/>
+          </p:cNvPicPr>
+          <p:nvPr>
+            <p:ph sz="half" idx="1"/>
+          </p:nvPr>
+        </p:nvPicPr>
+        <p:blipFill>
+          <a:blip r:embed="rId2"/>
+          <a:stretch>
+            <a:fillRect/>
+          </a:stretch>
+        </p:blipFill>
+        <p:spPr>
+          <a:xfrm>
+            <a:off x="457200" y="1621039"/>
+            <a:ext cx="4038600" cy="4484285"/>
+          </a:xfrm>
+          <a:prstGeom prst="rect">
+            <a:avLst/>
+          </a:prstGeom>
+        </p:spPr>
+      </p:pic>
+      <p:pic>
+        <p:nvPicPr>
+          <p:cNvPr id="9" name="Picture 8">
+            <a:extLst>
+              <a:ext uri="{FF2B5EF4-FFF2-40B4-BE49-F238E27FC236}">
+                <a16:creationId xmlns:a16="http://schemas.microsoft.com/office/drawing/2014/main" id="{113D6809-280D-A5E6-2D24-8E32D2790D69}"/>
+              </a:ext>
+            </a:extLst>
+          </p:cNvPr>
+          <p:cNvPicPr>
+            <a:picLocks noChangeAspect="1"/>
+          </p:cNvPicPr>
+          <p:nvPr/>
+        </p:nvPicPr>
+        <p:blipFill>
+          <a:blip r:embed="rId3"/>
+          <a:stretch>
+            <a:fillRect/>
+          </a:stretch>
+        </p:blipFill>
+        <p:spPr>
+          <a:xfrm>
+            <a:off x="4783493" y="1621039"/>
+            <a:ext cx="3848357" cy="4488465"/>
+          </a:xfrm>
+          <a:prstGeom prst="rect">
+            <a:avLst/>
+          </a:prstGeom>
+        </p:spPr>
+      </p:pic>
     </p:spTree>
     <p:extLst>
       <p:ext uri="{BB962C8B-B14F-4D97-AF65-F5344CB8AC3E}">
-        <p14:creationId xmlns:p14="http://schemas.microsoft.com/office/powerpoint/2010/main" val="1034841680"/>
+        <p14:creationId xmlns:p14="http://schemas.microsoft.com/office/powerpoint/2010/main" val="1959674139"/>
       </p:ext>
     </p:extLst>
   </p:cSld>
@@ -4341,7 +4426,7 @@
         <p:spPr>
           <a:xfrm>
             <a:off x="457200" y="1633727"/>
-            <a:ext cx="4114800" cy="4492435"/>
+            <a:ext cx="8040624" cy="4492435"/>
           </a:xfrm>
         </p:spPr>
         <p:txBody>
@@ -5563,10 +5648,10 @@
       </p:sp>
       <p:pic>
         <p:nvPicPr>
-          <p:cNvPr id="4" name="Picture 3">
+          <p:cNvPr id="5" name="Picture 4">
             <a:extLst>
               <a:ext uri="{FF2B5EF4-FFF2-40B4-BE49-F238E27FC236}">
-                <a16:creationId xmlns:a16="http://schemas.microsoft.com/office/drawing/2014/main" id="{CAD4B60D-ACF3-2F7D-A592-412161FCE034}"/>
+                <a16:creationId xmlns:a16="http://schemas.microsoft.com/office/drawing/2014/main" id="{CB8F2EAB-A54F-5EF7-D31D-A948D04BC392}"/>
               </a:ext>
             </a:extLst>
           </p:cNvPr>
@@ -5583,8 +5668,8 @@
         </p:blipFill>
         <p:spPr>
           <a:xfrm>
-            <a:off x="800100" y="3683000"/>
-            <a:ext cx="7543800" cy="1574800"/>
+            <a:off x="685800" y="3644699"/>
+            <a:ext cx="7772400" cy="1860697"/>
           </a:xfrm>
           <a:prstGeom prst="rect">
             <a:avLst/>
@@ -6054,6 +6139,84 @@
         <p:cNvPr id="1" name="">
           <a:extLst>
             <a:ext uri="{FF2B5EF4-FFF2-40B4-BE49-F238E27FC236}">
+              <a16:creationId xmlns:a16="http://schemas.microsoft.com/office/drawing/2014/main" id="{2198EAD8-1C28-CB05-398D-86D3D4836CEB}"/>
+            </a:ext>
+          </a:extLst>
+        </p:cNvPr>
+        <p:cNvGrpSpPr/>
+        <p:nvPr/>
+      </p:nvGrpSpPr>
+      <p:grpSpPr>
+        <a:xfrm>
+          <a:off x="0" y="0"/>
+          <a:ext cx="0" cy="0"/>
+          <a:chOff x="0" y="0"/>
+          <a:chExt cx="0" cy="0"/>
+        </a:xfrm>
+      </p:grpSpPr>
+      <p:sp>
+        <p:nvSpPr>
+          <p:cNvPr id="2" name="Title 1">
+            <a:extLst>
+              <a:ext uri="{FF2B5EF4-FFF2-40B4-BE49-F238E27FC236}">
+                <a16:creationId xmlns:a16="http://schemas.microsoft.com/office/drawing/2014/main" id="{F72B8ECE-66CB-5F7D-1E40-CC592E98F43E}"/>
+              </a:ext>
+            </a:extLst>
+          </p:cNvPr>
+          <p:cNvSpPr>
+            <a:spLocks noGrp="1"/>
+          </p:cNvSpPr>
+          <p:nvPr>
+            <p:ph type="title"/>
+          </p:nvPr>
+        </p:nvSpPr>
+        <p:spPr>
+          <a:xfrm>
+            <a:off x="457200" y="2686812"/>
+            <a:ext cx="8229600" cy="1143000"/>
+          </a:xfrm>
+        </p:spPr>
+        <p:txBody>
+          <a:bodyPr/>
+          <a:lstStyle/>
+          <a:p>
+            <a:r>
+              <a:rPr dirty="0"/>
+              <a:t>Challenges</a:t>
+            </a:r>
+            <a:r>
+              <a:rPr lang="de-DE" dirty="0"/>
+              <a:t> </a:t>
+            </a:r>
+            <a:r>
+              <a:rPr lang="en-GB" dirty="0"/>
+              <a:t>&amp; Solutions</a:t>
+            </a:r>
+            <a:endParaRPr dirty="0"/>
+          </a:p>
+        </p:txBody>
+      </p:sp>
+    </p:spTree>
+    <p:extLst>
+      <p:ext uri="{BB962C8B-B14F-4D97-AF65-F5344CB8AC3E}">
+        <p14:creationId xmlns:p14="http://schemas.microsoft.com/office/powerpoint/2010/main" val="1034841680"/>
+      </p:ext>
+    </p:extLst>
+  </p:cSld>
+  <p:clrMapOvr>
+    <a:masterClrMapping/>
+  </p:clrMapOvr>
+</p:sld>
+</file>
+
+<file path=ppt/slides/slide5.xml><?xml version="1.0" encoding="utf-8"?>
+<p:sld xmlns:a="http://schemas.openxmlformats.org/drawingml/2006/main" xmlns:r="http://schemas.openxmlformats.org/officeDocument/2006/relationships" xmlns:p="http://schemas.openxmlformats.org/presentationml/2006/main">
+  <p:cSld>
+    <p:spTree>
+      <p:nvGrpSpPr>
+        <p:cNvPr id="1" name="">
+          <a:extLst>
+            <a:ext uri="{FF2B5EF4-FFF2-40B4-BE49-F238E27FC236}">
               <a16:creationId xmlns:a16="http://schemas.microsoft.com/office/drawing/2014/main" id="{535C8BF8-8E4C-1057-E7C8-B16459258960}"/>
             </a:ext>
           </a:extLst>
@@ -6151,7 +6314,7 @@
 </p:sld>
 </file>
 
-<file path=ppt/slides/slide5.xml><?xml version="1.0" encoding="utf-8"?>
+<file path=ppt/slides/slide6.xml><?xml version="1.0" encoding="utf-8"?>
 <p:sld xmlns:a="http://schemas.openxmlformats.org/drawingml/2006/main" xmlns:r="http://schemas.openxmlformats.org/officeDocument/2006/relationships" xmlns:p="http://schemas.openxmlformats.org/presentationml/2006/main">
   <p:cSld>
     <p:spTree>
@@ -6308,7 +6471,7 @@
 </p:sld>
 </file>
 
-<file path=ppt/slides/slide6.xml><?xml version="1.0" encoding="utf-8"?>
+<file path=ppt/slides/slide7.xml><?xml version="1.0" encoding="utf-8"?>
 <p:sld xmlns:a="http://schemas.openxmlformats.org/drawingml/2006/main" xmlns:r="http://schemas.openxmlformats.org/officeDocument/2006/relationships" xmlns:p="http://schemas.openxmlformats.org/presentationml/2006/main">
   <p:cSld>
     <p:spTree>
@@ -6471,7 +6634,7 @@
 </p:sld>
 </file>
 
-<file path=ppt/slides/slide7.xml><?xml version="1.0" encoding="utf-8"?>
+<file path=ppt/slides/slide8.xml><?xml version="1.0" encoding="utf-8"?>
 <p:sld xmlns:a="http://schemas.openxmlformats.org/drawingml/2006/main" xmlns:r="http://schemas.openxmlformats.org/officeDocument/2006/relationships" xmlns:p="http://schemas.openxmlformats.org/presentationml/2006/main">
   <p:cSld>
     <p:spTree>
@@ -6572,7 +6735,7 @@
 </p:sld>
 </file>
 
-<file path=ppt/slides/slide8.xml><?xml version="1.0" encoding="utf-8"?>
+<file path=ppt/slides/slide9.xml><?xml version="1.0" encoding="utf-8"?>
 <p:sld xmlns:a="http://schemas.openxmlformats.org/drawingml/2006/main" xmlns:r="http://schemas.openxmlformats.org/officeDocument/2006/relationships" xmlns:p="http://schemas.openxmlformats.org/presentationml/2006/main">
   <p:cSld>
     <p:spTree>
@@ -6726,169 +6889,6 @@
     <p:extLst>
       <p:ext uri="{BB962C8B-B14F-4D97-AF65-F5344CB8AC3E}">
         <p14:creationId xmlns:p14="http://schemas.microsoft.com/office/powerpoint/2010/main" val="1869144857"/>
-      </p:ext>
-    </p:extLst>
-  </p:cSld>
-  <p:clrMapOvr>
-    <a:masterClrMapping/>
-  </p:clrMapOvr>
-</p:sld>
-</file>
-
-<file path=ppt/slides/slide9.xml><?xml version="1.0" encoding="utf-8"?>
-<p:sld xmlns:a="http://schemas.openxmlformats.org/drawingml/2006/main" xmlns:r="http://schemas.openxmlformats.org/officeDocument/2006/relationships" xmlns:p="http://schemas.openxmlformats.org/presentationml/2006/main">
-  <p:cSld>
-    <p:spTree>
-      <p:nvGrpSpPr>
-        <p:cNvPr id="1" name="">
-          <a:extLst>
-            <a:ext uri="{FF2B5EF4-FFF2-40B4-BE49-F238E27FC236}">
-              <a16:creationId xmlns:a16="http://schemas.microsoft.com/office/drawing/2014/main" id="{25C9A356-CBAE-6B60-CB48-069FC9518257}"/>
-            </a:ext>
-          </a:extLst>
-        </p:cNvPr>
-        <p:cNvGrpSpPr/>
-        <p:nvPr/>
-      </p:nvGrpSpPr>
-      <p:grpSpPr>
-        <a:xfrm>
-          <a:off x="0" y="0"/>
-          <a:ext cx="0" cy="0"/>
-          <a:chOff x="0" y="0"/>
-          <a:chExt cx="0" cy="0"/>
-        </a:xfrm>
-      </p:grpSpPr>
-      <p:sp>
-        <p:nvSpPr>
-          <p:cNvPr id="2" name="Title 1">
-            <a:extLst>
-              <a:ext uri="{FF2B5EF4-FFF2-40B4-BE49-F238E27FC236}">
-                <a16:creationId xmlns:a16="http://schemas.microsoft.com/office/drawing/2014/main" id="{565CC8EE-D829-2C12-7234-56575CE39B81}"/>
-              </a:ext>
-            </a:extLst>
-          </p:cNvPr>
-          <p:cNvSpPr>
-            <a:spLocks noGrp="1"/>
-          </p:cNvSpPr>
-          <p:nvPr>
-            <p:ph type="title"/>
-          </p:nvPr>
-        </p:nvSpPr>
-        <p:spPr/>
-        <p:txBody>
-          <a:bodyPr/>
-          <a:lstStyle/>
-          <a:p>
-            <a:r>
-              <a:rPr lang="en-GB" dirty="0"/>
-              <a:t>Updated State Machine</a:t>
-            </a:r>
-            <a:endParaRPr lang="en-DE" dirty="0"/>
-          </a:p>
-        </p:txBody>
-      </p:sp>
-      <p:sp>
-        <p:nvSpPr>
-          <p:cNvPr id="16" name="Content Placeholder 15">
-            <a:extLst>
-              <a:ext uri="{FF2B5EF4-FFF2-40B4-BE49-F238E27FC236}">
-                <a16:creationId xmlns:a16="http://schemas.microsoft.com/office/drawing/2014/main" id="{9E6654EA-C65E-985C-974A-E732CD5C4631}"/>
-              </a:ext>
-            </a:extLst>
-          </p:cNvPr>
-          <p:cNvSpPr>
-            <a:spLocks noGrp="1"/>
-          </p:cNvSpPr>
-          <p:nvPr>
-            <p:ph sz="half" idx="2"/>
-          </p:nvPr>
-        </p:nvSpPr>
-        <p:spPr>
-          <a:xfrm>
-            <a:off x="4572000" y="1699054"/>
-            <a:ext cx="4271344" cy="4525963"/>
-          </a:xfrm>
-        </p:spPr>
-        <p:txBody>
-          <a:bodyPr/>
-          <a:lstStyle/>
-          <a:p>
-            <a:pPr marL="0" indent="0">
-              <a:buNone/>
-            </a:pPr>
-            <a:br>
-              <a:rPr lang="en-DE" dirty="0"/>
-            </a:br>
-            <a:endParaRPr lang="en-DE" dirty="0"/>
-          </a:p>
-        </p:txBody>
-      </p:sp>
-      <p:pic>
-        <p:nvPicPr>
-          <p:cNvPr id="7" name="Content Placeholder 6">
-            <a:extLst>
-              <a:ext uri="{FF2B5EF4-FFF2-40B4-BE49-F238E27FC236}">
-                <a16:creationId xmlns:a16="http://schemas.microsoft.com/office/drawing/2014/main" id="{6B8AFFCB-4070-D76C-B10F-3CB62202C9B8}"/>
-              </a:ext>
-            </a:extLst>
-          </p:cNvPr>
-          <p:cNvPicPr>
-            <a:picLocks noGrp="1" noChangeAspect="1"/>
-          </p:cNvPicPr>
-          <p:nvPr>
-            <p:ph sz="half" idx="1"/>
-          </p:nvPr>
-        </p:nvPicPr>
-        <p:blipFill>
-          <a:blip r:embed="rId2"/>
-          <a:stretch>
-            <a:fillRect/>
-          </a:stretch>
-        </p:blipFill>
-        <p:spPr>
-          <a:xfrm>
-            <a:off x="457200" y="1621039"/>
-            <a:ext cx="4038600" cy="4484285"/>
-          </a:xfrm>
-          <a:prstGeom prst="rect">
-            <a:avLst/>
-          </a:prstGeom>
-        </p:spPr>
-      </p:pic>
-      <p:pic>
-        <p:nvPicPr>
-          <p:cNvPr id="9" name="Picture 8">
-            <a:extLst>
-              <a:ext uri="{FF2B5EF4-FFF2-40B4-BE49-F238E27FC236}">
-                <a16:creationId xmlns:a16="http://schemas.microsoft.com/office/drawing/2014/main" id="{113D6809-280D-A5E6-2D24-8E32D2790D69}"/>
-              </a:ext>
-            </a:extLst>
-          </p:cNvPr>
-          <p:cNvPicPr>
-            <a:picLocks noChangeAspect="1"/>
-          </p:cNvPicPr>
-          <p:nvPr/>
-        </p:nvPicPr>
-        <p:blipFill>
-          <a:blip r:embed="rId3"/>
-          <a:stretch>
-            <a:fillRect/>
-          </a:stretch>
-        </p:blipFill>
-        <p:spPr>
-          <a:xfrm>
-            <a:off x="4783493" y="1621039"/>
-            <a:ext cx="3848357" cy="4488465"/>
-          </a:xfrm>
-          <a:prstGeom prst="rect">
-            <a:avLst/>
-          </a:prstGeom>
-        </p:spPr>
-      </p:pic>
-    </p:spTree>
-    <p:extLst>
-      <p:ext uri="{BB962C8B-B14F-4D97-AF65-F5344CB8AC3E}">
-        <p14:creationId xmlns:p14="http://schemas.microsoft.com/office/powerpoint/2010/main" val="1959674139"/>
       </p:ext>
     </p:extLst>
   </p:cSld>

</xml_diff>

<commit_message>
Edited the final Presentation
</commit_message>
<xml_diff>
--- a/Presentation.pptx
+++ b/Presentation.pptx
@@ -323,7 +323,7 @@
           <a:p>
             <a:fld id="{5BCAD085-E8A6-8845-BD4E-CB4CCA059FC4}" type="datetimeFigureOut">
               <a:rPr lang="en-US" smtClean="0"/>
-              <a:t>6/22/25</a:t>
+              <a:t>6/22/2025</a:t>
             </a:fld>
             <a:endParaRPr lang="en-US"/>
           </a:p>
@@ -491,7 +491,7 @@
           <a:p>
             <a:fld id="{5BCAD085-E8A6-8845-BD4E-CB4CCA059FC4}" type="datetimeFigureOut">
               <a:rPr lang="en-US" smtClean="0"/>
-              <a:t>6/22/25</a:t>
+              <a:t>6/22/2025</a:t>
             </a:fld>
             <a:endParaRPr lang="en-US"/>
           </a:p>
@@ -669,7 +669,7 @@
           <a:p>
             <a:fld id="{5BCAD085-E8A6-8845-BD4E-CB4CCA059FC4}" type="datetimeFigureOut">
               <a:rPr lang="en-US" smtClean="0"/>
-              <a:t>6/22/25</a:t>
+              <a:t>6/22/2025</a:t>
             </a:fld>
             <a:endParaRPr lang="en-US"/>
           </a:p>
@@ -837,7 +837,7 @@
           <a:p>
             <a:fld id="{5BCAD085-E8A6-8845-BD4E-CB4CCA059FC4}" type="datetimeFigureOut">
               <a:rPr lang="en-US" smtClean="0"/>
-              <a:t>6/22/25</a:t>
+              <a:t>6/22/2025</a:t>
             </a:fld>
             <a:endParaRPr lang="en-US"/>
           </a:p>
@@ -1082,7 +1082,7 @@
           <a:p>
             <a:fld id="{5BCAD085-E8A6-8845-BD4E-CB4CCA059FC4}" type="datetimeFigureOut">
               <a:rPr lang="en-US" smtClean="0"/>
-              <a:t>6/22/25</a:t>
+              <a:t>6/22/2025</a:t>
             </a:fld>
             <a:endParaRPr lang="en-US"/>
           </a:p>
@@ -1367,7 +1367,7 @@
           <a:p>
             <a:fld id="{5BCAD085-E8A6-8845-BD4E-CB4CCA059FC4}" type="datetimeFigureOut">
               <a:rPr lang="en-US" smtClean="0"/>
-              <a:t>6/22/25</a:t>
+              <a:t>6/22/2025</a:t>
             </a:fld>
             <a:endParaRPr lang="en-US"/>
           </a:p>
@@ -1786,7 +1786,7 @@
           <a:p>
             <a:fld id="{5BCAD085-E8A6-8845-BD4E-CB4CCA059FC4}" type="datetimeFigureOut">
               <a:rPr lang="en-US" smtClean="0"/>
-              <a:t>6/22/25</a:t>
+              <a:t>6/22/2025</a:t>
             </a:fld>
             <a:endParaRPr lang="en-US"/>
           </a:p>
@@ -1903,7 +1903,7 @@
           <a:p>
             <a:fld id="{5BCAD085-E8A6-8845-BD4E-CB4CCA059FC4}" type="datetimeFigureOut">
               <a:rPr lang="en-US" smtClean="0"/>
-              <a:t>6/22/25</a:t>
+              <a:t>6/22/2025</a:t>
             </a:fld>
             <a:endParaRPr lang="en-US"/>
           </a:p>
@@ -1998,7 +1998,7 @@
           <a:p>
             <a:fld id="{5BCAD085-E8A6-8845-BD4E-CB4CCA059FC4}" type="datetimeFigureOut">
               <a:rPr lang="en-US" smtClean="0"/>
-              <a:t>6/22/25</a:t>
+              <a:t>6/22/2025</a:t>
             </a:fld>
             <a:endParaRPr lang="en-US"/>
           </a:p>
@@ -2273,7 +2273,7 @@
           <a:p>
             <a:fld id="{5BCAD085-E8A6-8845-BD4E-CB4CCA059FC4}" type="datetimeFigureOut">
               <a:rPr lang="en-US" smtClean="0"/>
-              <a:t>6/22/25</a:t>
+              <a:t>6/22/2025</a:t>
             </a:fld>
             <a:endParaRPr lang="en-US"/>
           </a:p>
@@ -2525,7 +2525,7 @@
           <a:p>
             <a:fld id="{5BCAD085-E8A6-8845-BD4E-CB4CCA059FC4}" type="datetimeFigureOut">
               <a:rPr lang="en-US" smtClean="0"/>
-              <a:t>6/22/25</a:t>
+              <a:t>6/22/2025</a:t>
             </a:fld>
             <a:endParaRPr lang="en-US"/>
           </a:p>
@@ -2766,7 +2766,7 @@
           <a:p>
             <a:fld id="{5BCAD085-E8A6-8845-BD4E-CB4CCA059FC4}" type="datetimeFigureOut">
               <a:rPr lang="en-US" smtClean="0"/>
-              <a:t>6/22/25</a:t>
+              <a:t>6/22/2025</a:t>
             </a:fld>
             <a:endParaRPr lang="en-US"/>
           </a:p>
@@ -3579,7 +3579,7 @@
             </a:pPr>
             <a:r>
               <a:rPr lang="en-GB" sz="2400" dirty="0"/>
-              <a:t>After printing testing these parts on the actual hardware they did not fit well due to real-world imperfections and printer tolerances.</a:t>
+              <a:t>After printing testing these parts on the actual chassis, they did not fit well due to real-world imperfections and the 3D printer errors.</a:t>
             </a:r>
           </a:p>
           <a:p>
@@ -3713,7 +3713,10 @@
               <a:buFont typeface="Wingdings" pitchFamily="2" charset="2"/>
               <a:buChar char="ü"/>
             </a:pPr>
-            <a:endParaRPr lang="en-GB" sz="2600" dirty="0"/>
+            <a:r>
+              <a:rPr lang="en-GB" sz="2600" dirty="0"/>
+              <a:t>Included some tolerances in the designed parts to compensate errors resulted from printing</a:t>
+            </a:r>
           </a:p>
           <a:p>
             <a:pPr>
@@ -3722,8 +3725,21 @@
             </a:pPr>
             <a:r>
               <a:rPr lang="en-GB" sz="2600" dirty="0"/>
-              <a:t>Included tolerances and features that could let us to modify and fine-tune the parts after the printing with simple tools (cutters, files, extra screws and washers).</a:t>
-            </a:r>
+              <a:t>Added slots to the IR sensor mounts to enable easy location tuning without constraints.</a:t>
+            </a:r>
+          </a:p>
+          <a:p>
+            <a:pPr>
+              <a:buFont typeface="Wingdings" pitchFamily="2" charset="2"/>
+              <a:buChar char="ü"/>
+            </a:pPr>
+            <a:endParaRPr lang="en-GB" sz="2600" dirty="0"/>
+          </a:p>
+          <a:p>
+            <a:pPr>
+              <a:buFont typeface="Wingdings" pitchFamily="2" charset="2"/>
+              <a:buChar char="ü"/>
+            </a:pPr>
             <a:endParaRPr sz="2600" dirty="0"/>
           </a:p>
         </p:txBody>
@@ -4319,7 +4335,7 @@
             </a:pPr>
             <a:r>
               <a:rPr lang="en-GB" sz="2400" dirty="0"/>
-              <a:t>In the construction, the battery was placed at the front of the vehicle for easy access.</a:t>
+              <a:t>In the initial design, the battery was placed at the front of the vehicle horizontally for easy access.</a:t>
             </a:r>
           </a:p>
           <a:p>
@@ -4336,7 +4352,7 @@
             </a:pPr>
             <a:r>
               <a:rPr lang="en-GB" sz="2400" dirty="0"/>
-              <a:t>During testing, this caused a critical imbalance, preventing the wheels from gaining proper traction. The vehicle struggled to move correctly.</a:t>
+              <a:t>During testing, this caused a critical imbalance, preventing the wheels from gaining proper traction. Thus, The vehicle struggled to move correctly.</a:t>
             </a:r>
             <a:endParaRPr dirty="0"/>
           </a:p>
@@ -4473,7 +4489,7 @@
             </a:pPr>
             <a:r>
               <a:rPr lang="en-GB" sz="2400" dirty="0"/>
-              <a:t>This balanced the weight distribution, allowing the wheels to function properly.</a:t>
+              <a:t>This shifted the centre of gravity to the back, allowing the wheels to function properly.</a:t>
             </a:r>
             <a:endParaRPr sz="2400" dirty="0"/>
           </a:p>
@@ -4769,7 +4785,7 @@
             </a:pPr>
             <a:r>
               <a:rPr lang="en-GB" sz="2400" dirty="0"/>
-              <a:t>The physical distance between our two IR sensors was wider than the actual black line used on the track.</a:t>
+              <a:t>The physical distance between our two IR sensors was much wider than the actual black line used on the track.</a:t>
             </a:r>
           </a:p>
           <a:p>
@@ -4927,7 +4943,7 @@
             </a:pPr>
             <a:r>
               <a:rPr lang="en-GB" sz="2600" dirty="0"/>
-              <a:t>Adjusted the Code, inverting the line detection to HIGH instead of LOW without changing sensor mounting or wiring.</a:t>
+              <a:t>Adjusted the Code, inverting the line detection to HIGH instead of LOW </a:t>
             </a:r>
           </a:p>
           <a:p>
@@ -4937,7 +4953,7 @@
             </a:pPr>
             <a:r>
               <a:rPr lang="en-GB" sz="2600" dirty="0"/>
-              <a:t>It allowed existing sensor spacing and track design to function perfectly, with reliable line tracking.</a:t>
+              <a:t>Adjusted the sensor spacing to be reasonable relative to the line thickness</a:t>
             </a:r>
           </a:p>
         </p:txBody>

</xml_diff>